<commit_message>
feat: adiciona slides sobre funcionamento e pattern matching da IQL
</commit_message>
<xml_diff>
--- a/Apresentacao_Spectrum_Editavel.pptx
+++ b/Apresentacao_Spectrum_Editavel.pptx
@@ -36,6 +36,8 @@
     <p:sldId id="284" r:id="rId35"/>
     <p:sldId id="285" r:id="rId36"/>
     <p:sldId id="286" r:id="rId37"/>
+    <p:sldId id="287" r:id="rId38"/>
+    <p:sldId id="288" r:id="rId39"/>
   </p:sldIdLst>
   <p:sldSz cx="12191695" cy="6858000" type="screen4x3"/>
   <p:notesSz cx="6858000" cy="9144000"/>
@@ -4402,6 +4404,182 @@
           <a:lstStyle/>
           <a:p>
             <a:r>
+              <a:t>O Pipeline de Execução da IQL</a:t>
+            </a:r>
+          </a:p>
+        </p:txBody>
+      </p:sp>
+      <p:sp>
+        <p:nvSpPr>
+          <p:cNvPr id="3" name="Content Placeholder 2"/>
+          <p:cNvSpPr>
+            <a:spLocks noGrp="1"/>
+          </p:cNvSpPr>
+          <p:nvPr>
+            <p:ph idx="1"/>
+          </p:nvPr>
+        </p:nvSpPr>
+        <p:spPr/>
+        <p:txBody>
+          <a:bodyPr/>
+          <a:lstStyle/>
+          <a:p/>
+          <a:p>
+            <a:pPr>
+              <a:defRPr sz="2200"/>
+            </a:pPr>
+            <a:r>
+              <a:t>A execução das consultas IQL roda em um interpretador e compilador próprio (Parser) construído do zero na plataforma:</a:t>
+            </a:r>
+          </a:p>
+          <a:p>
+            <a:pPr lvl="1">
+              <a:defRPr sz="2000"/>
+            </a:pPr>
+            <a:r>
+              <a:t>Análise Léxica (Tokenização): Converte a consulta textual em tokens validando a sintaxe e a semântica de forma robusta.</a:t>
+            </a:r>
+          </a:p>
+          <a:p>
+            <a:pPr lvl="1">
+              <a:defRPr sz="2000"/>
+            </a:pPr>
+            <a:r>
+              <a:t>Análise Sintática (Pratt Parser): Transforma os tokens em uma Árvore de Sintaxe Abstrata (AST) representativa da própria consulta do usuário.</a:t>
+            </a:r>
+          </a:p>
+          <a:p>
+            <a:pPr lvl="1">
+              <a:defRPr sz="2000"/>
+            </a:pPr>
+            <a:r>
+              <a:t>Integração Nativa: O motor executa a AST compilada diretamente contra o e-graph carregado em memória, garantindo altíssimo desempenho na extração massiva.</a:t>
+            </a:r>
+          </a:p>
+        </p:txBody>
+      </p:sp>
+    </p:spTree>
+  </p:cSld>
+  <p:clrMapOvr>
+    <a:masterClrMapping/>
+  </p:clrMapOvr>
+</p:sld>
+</file>
+
+<file path=ppt/slides/slide23.xml><?xml version="1.0" encoding="utf-8"?>
+<p:sld xmlns:a="http://schemas.openxmlformats.org/drawingml/2006/main" xmlns:p="http://schemas.openxmlformats.org/presentationml/2006/main" xmlns:r="http://schemas.openxmlformats.org/officeDocument/2006/relationships">
+  <p:cSld>
+    <p:spTree>
+      <p:nvGrpSpPr>
+        <p:cNvPr id="1" name=""/>
+        <p:cNvGrpSpPr/>
+        <p:nvPr/>
+      </p:nvGrpSpPr>
+      <p:grpSpPr/>
+      <p:sp>
+        <p:nvSpPr>
+          <p:cNvPr id="2" name="Title 1"/>
+          <p:cNvSpPr>
+            <a:spLocks noGrp="1"/>
+          </p:cNvSpPr>
+          <p:nvPr>
+            <p:ph type="title"/>
+          </p:nvPr>
+        </p:nvSpPr>
+        <p:spPr/>
+        <p:txBody>
+          <a:bodyPr/>
+          <a:lstStyle/>
+          <a:p>
+            <a:r>
+              <a:t>Casamento de Padrões (Pattern Matching)</a:t>
+            </a:r>
+          </a:p>
+        </p:txBody>
+      </p:sp>
+      <p:sp>
+        <p:nvSpPr>
+          <p:cNvPr id="3" name="Content Placeholder 2"/>
+          <p:cNvSpPr>
+            <a:spLocks noGrp="1"/>
+          </p:cNvSpPr>
+          <p:nvPr>
+            <p:ph idx="1"/>
+          </p:nvPr>
+        </p:nvSpPr>
+        <p:spPr/>
+        <p:txBody>
+          <a:bodyPr/>
+          <a:lstStyle/>
+          <a:p/>
+          <a:p>
+            <a:pPr lvl="1">
+              <a:defRPr sz="2000"/>
+            </a:pPr>
+            <a:r>
+              <a:t>O verdadeiro poder da IQL reside na sua integração com algoritmos de Pattern Matching aplicados em grafos.</a:t>
+            </a:r>
+          </a:p>
+          <a:p>
+            <a:pPr lvl="1">
+              <a:defRPr sz="2000"/>
+            </a:pPr>
+            <a:r>
+              <a:t>A diretiva PATTERN IS LIKE instrui o motor a varrer o e-graph procurando equações que respeitem um esqueleto matemático específico (ex: sin(v0) * v1).</a:t>
+            </a:r>
+          </a:p>
+          <a:p>
+            <a:pPr lvl="1">
+              <a:defRPr sz="2000"/>
+            </a:pPr>
+            <a:r>
+              <a:t>Garante que as expressões extraídas façam total sentido para as regras de negócio ou físicas do especialista, injetando conhecimento humano na filtragem.</a:t>
+            </a:r>
+          </a:p>
+          <a:p>
+            <a:pPr>
+              <a:defRPr sz="2200"/>
+            </a:pPr>
+            <a:r>
+              <a:t>"A capacidade de filtrar expressões que respeitem características estruturais pré-estabelecidas torna o processo alinhado aos conhecimentos prévios do especialista de domínio."</a:t>
+            </a:r>
+          </a:p>
+        </p:txBody>
+      </p:sp>
+    </p:spTree>
+  </p:cSld>
+  <p:clrMapOvr>
+    <a:masterClrMapping/>
+  </p:clrMapOvr>
+</p:sld>
+</file>
+
+<file path=ppt/slides/slide24.xml><?xml version="1.0" encoding="utf-8"?>
+<p:sld xmlns:a="http://schemas.openxmlformats.org/drawingml/2006/main" xmlns:p="http://schemas.openxmlformats.org/presentationml/2006/main" xmlns:r="http://schemas.openxmlformats.org/officeDocument/2006/relationships">
+  <p:cSld>
+    <p:spTree>
+      <p:nvGrpSpPr>
+        <p:cNvPr id="1" name=""/>
+        <p:cNvGrpSpPr/>
+        <p:nvPr/>
+      </p:nvGrpSpPr>
+      <p:grpSpPr/>
+      <p:sp>
+        <p:nvSpPr>
+          <p:cNvPr id="2" name="Title 1"/>
+          <p:cNvSpPr>
+            <a:spLocks noGrp="1"/>
+          </p:cNvSpPr>
+          <p:nvPr>
+            <p:ph type="title"/>
+          </p:nvPr>
+        </p:nvSpPr>
+        <p:spPr/>
+        <p:txBody>
+          <a:bodyPr/>
+          <a:lstStyle/>
+          <a:p>
+            <a:r>
               <a:t>Exploração e Filtros Avançados</a:t>
             </a:r>
           </a:p>
@@ -4472,7 +4650,7 @@
 </p:sld>
 </file>
 
-<file path=ppt/slides/slide23.xml><?xml version="1.0" encoding="utf-8"?>
+<file path=ppt/slides/slide25.xml><?xml version="1.0" encoding="utf-8"?>
 <p:sld xmlns:a="http://schemas.openxmlformats.org/drawingml/2006/main" xmlns:p="http://schemas.openxmlformats.org/presentationml/2006/main" xmlns:r="http://schemas.openxmlformats.org/officeDocument/2006/relationships">
   <p:cSld>
     <p:spTree>
@@ -4576,7 +4754,7 @@
 </p:sld>
 </file>
 
-<file path=ppt/slides/slide24.xml><?xml version="1.0" encoding="utf-8"?>
+<file path=ppt/slides/slide26.xml><?xml version="1.0" encoding="utf-8"?>
 <p:sld xmlns:a="http://schemas.openxmlformats.org/drawingml/2006/main" xmlns:p="http://schemas.openxmlformats.org/presentationml/2006/main" xmlns:r="http://schemas.openxmlformats.org/officeDocument/2006/relationships">
   <p:cSld>
     <p:spTree>
@@ -4680,7 +4858,7 @@
 </p:sld>
 </file>
 
-<file path=ppt/slides/slide25.xml><?xml version="1.0" encoding="utf-8"?>
+<file path=ppt/slides/slide27.xml><?xml version="1.0" encoding="utf-8"?>
 <p:sld xmlns:a="http://schemas.openxmlformats.org/drawingml/2006/main" xmlns:p="http://schemas.openxmlformats.org/presentationml/2006/main" xmlns:r="http://schemas.openxmlformats.org/officeDocument/2006/relationships">
   <p:cSld>
     <p:spTree>
@@ -4784,7 +4962,7 @@
 </p:sld>
 </file>
 
-<file path=ppt/slides/slide26.xml><?xml version="1.0" encoding="utf-8"?>
+<file path=ppt/slides/slide28.xml><?xml version="1.0" encoding="utf-8"?>
 <p:sld xmlns:a="http://schemas.openxmlformats.org/drawingml/2006/main" xmlns:p="http://schemas.openxmlformats.org/presentationml/2006/main" xmlns:r="http://schemas.openxmlformats.org/officeDocument/2006/relationships">
   <p:cSld>
     <p:spTree>
@@ -4888,7 +5066,7 @@
 </p:sld>
 </file>
 
-<file path=ppt/slides/slide27.xml><?xml version="1.0" encoding="utf-8"?>
+<file path=ppt/slides/slide29.xml><?xml version="1.0" encoding="utf-8"?>
 <p:sld xmlns:a="http://schemas.openxmlformats.org/drawingml/2006/main" xmlns:p="http://schemas.openxmlformats.org/presentationml/2006/main" xmlns:r="http://schemas.openxmlformats.org/officeDocument/2006/relationships">
   <p:cSld>
     <p:spTree>
@@ -4984,150 +5162,6 @@
 </p:sld>
 </file>
 
-<file path=ppt/slides/slide28.xml><?xml version="1.0" encoding="utf-8"?>
-<p:sld xmlns:a="http://schemas.openxmlformats.org/drawingml/2006/main" xmlns:p="http://schemas.openxmlformats.org/presentationml/2006/main" xmlns:r="http://schemas.openxmlformats.org/officeDocument/2006/relationships">
-  <p:cSld>
-    <p:spTree>
-      <p:nvGrpSpPr>
-        <p:cNvPr id="1" name=""/>
-        <p:cNvGrpSpPr/>
-        <p:nvPr/>
-      </p:nvGrpSpPr>
-      <p:grpSpPr/>
-      <p:sp>
-        <p:nvSpPr>
-          <p:cNvPr id="2" name="Title 1"/>
-          <p:cNvSpPr>
-            <a:spLocks noGrp="1"/>
-          </p:cNvSpPr>
-          <p:nvPr>
-            <p:ph type="title"/>
-          </p:nvPr>
-        </p:nvSpPr>
-        <p:spPr/>
-        <p:txBody>
-          <a:bodyPr/>
-          <a:lstStyle/>
-          <a:p>
-            <a:r>
-              <a:t>Comparação Analítica de Plataformas</a:t>
-            </a:r>
-          </a:p>
-        </p:txBody>
-      </p:sp>
-      <p:sp>
-        <p:nvSpPr>
-          <p:cNvPr id="3" name="Content Placeholder 2"/>
-          <p:cNvSpPr>
-            <a:spLocks noGrp="1"/>
-          </p:cNvSpPr>
-          <p:nvPr>
-            <p:ph idx="1"/>
-          </p:nvPr>
-        </p:nvSpPr>
-        <p:spPr/>
-        <p:txBody>
-          <a:bodyPr/>
-          <a:lstStyle/>
-          <a:p/>
-          <a:p>
-            <a:pPr>
-              <a:defRPr sz="2200"/>
-            </a:pPr>
-            <a:r>
-              <a:t>Comparação de funcionalidades essenciais para pesquisa em Regressão Simbólica.</a:t>
-            </a:r>
-          </a:p>
-        </p:txBody>
-      </p:sp>
-    </p:spTree>
-  </p:cSld>
-  <p:clrMapOvr>
-    <a:masterClrMapping/>
-  </p:clrMapOvr>
-</p:sld>
-</file>
-
-<file path=ppt/slides/slide29.xml><?xml version="1.0" encoding="utf-8"?>
-<p:sld xmlns:a="http://schemas.openxmlformats.org/drawingml/2006/main" xmlns:p="http://schemas.openxmlformats.org/presentationml/2006/main" xmlns:r="http://schemas.openxmlformats.org/officeDocument/2006/relationships">
-  <p:cSld>
-    <p:spTree>
-      <p:nvGrpSpPr>
-        <p:cNvPr id="1" name=""/>
-        <p:cNvGrpSpPr/>
-        <p:nvPr/>
-      </p:nvGrpSpPr>
-      <p:grpSpPr/>
-      <p:sp>
-        <p:nvSpPr>
-          <p:cNvPr id="2" name="Title 1"/>
-          <p:cNvSpPr>
-            <a:spLocks noGrp="1"/>
-          </p:cNvSpPr>
-          <p:nvPr>
-            <p:ph type="title"/>
-          </p:nvPr>
-        </p:nvSpPr>
-        <p:spPr/>
-        <p:txBody>
-          <a:bodyPr/>
-          <a:lstStyle/>
-          <a:p>
-            <a:r>
-              <a:t>Conclusão</a:t>
-            </a:r>
-          </a:p>
-        </p:txBody>
-      </p:sp>
-      <p:sp>
-        <p:nvSpPr>
-          <p:cNvPr id="3" name="Content Placeholder 2"/>
-          <p:cNvSpPr>
-            <a:spLocks noGrp="1"/>
-          </p:cNvSpPr>
-          <p:nvPr>
-            <p:ph idx="1"/>
-          </p:nvPr>
-        </p:nvSpPr>
-        <p:spPr/>
-        <p:txBody>
-          <a:bodyPr/>
-          <a:lstStyle/>
-          <a:p/>
-          <a:p>
-            <a:pPr lvl="1">
-              <a:defRPr sz="2000"/>
-            </a:pPr>
-            <a:r>
-              <a:t>A arquitetura distribuída do Spectrum provou que a transição de cargas pesadas para uma execução via filas destrava o treinamento exaustivo sem consumir o maquinário local do analista.</a:t>
-            </a:r>
-          </a:p>
-          <a:p>
-            <a:pPr lvl="1">
-              <a:defRPr sz="2000"/>
-            </a:pPr>
-            <a:r>
-              <a:t>A linguagem estruturada IQL quebra o modelo de observação estática de outras ferramentas, permitindo ao cientista a prospecção e extração guiada de regras específicas imersas nos e-graphs.</a:t>
-            </a:r>
-          </a:p>
-          <a:p>
-            <a:pPr lvl="1">
-              <a:defRPr sz="2000"/>
-            </a:pPr>
-            <a:r>
-              <a:t>Centralizar as visualizações otimizadas acopladas ao redator acadêmico agilizou com eficiência os fluxos metodológicos.</a:t>
-            </a:r>
-          </a:p>
-        </p:txBody>
-      </p:sp>
-    </p:spTree>
-  </p:cSld>
-  <p:clrMapOvr>
-    <a:masterClrMapping/>
-  </p:clrMapOvr>
-</p:sld>
-</file>
-
 <file path=ppt/slides/slide3.xml><?xml version="1.0" encoding="utf-8"?>
 <p:sld xmlns:a="http://schemas.openxmlformats.org/drawingml/2006/main" xmlns:p="http://schemas.openxmlformats.org/presentationml/2006/main" xmlns:r="http://schemas.openxmlformats.org/officeDocument/2006/relationships">
   <p:cSld>
@@ -5242,7 +5276,7 @@
           <a:lstStyle/>
           <a:p>
             <a:r>
-              <a:t>Trabalhos Futuros</a:t>
+              <a:t>Comparação Analítica de Plataformas</a:t>
             </a:r>
           </a:p>
         </p:txBody>
@@ -5263,27 +5297,11 @@
           <a:lstStyle/>
           <a:p/>
           <a:p>
-            <a:pPr lvl="1">
-              <a:defRPr sz="2000"/>
-            </a:pPr>
-            <a:r>
-              <a:t>Resiliência de Rede: Implantar o padrão arquitetural estrito no código do backend para garantir que nenhum processo se perca.</a:t>
-            </a:r>
-          </a:p>
-          <a:p>
-            <a:pPr lvl="1">
-              <a:defRPr sz="2000"/>
-            </a:pPr>
-            <a:r>
-              <a:t>Suporte Estendido: Possibilitar a integração opcional da camada de treinamento para interligar as execuções IQL aos motores otimizados em C++ (ex. PySR).</a:t>
-            </a:r>
-          </a:p>
-          <a:p>
-            <a:pPr lvl="1">
-              <a:defRPr sz="2000"/>
-            </a:pPr>
-            <a:r>
-              <a:t>Tipagens Textuais Avançadas: Expandir o processador de dados para abranger e validar representações em texto, provindas da computação através de embeddings numéricos.</a:t>
+            <a:pPr>
+              <a:defRPr sz="2200"/>
+            </a:pPr>
+            <a:r>
+              <a:t>Comparação de funcionalidades essenciais para pesquisa em Regressão Simbólica.</a:t>
             </a:r>
           </a:p>
         </p:txBody>
@@ -5297,6 +5315,166 @@
 </file>
 
 <file path=ppt/slides/slide31.xml><?xml version="1.0" encoding="utf-8"?>
+<p:sld xmlns:a="http://schemas.openxmlformats.org/drawingml/2006/main" xmlns:p="http://schemas.openxmlformats.org/presentationml/2006/main" xmlns:r="http://schemas.openxmlformats.org/officeDocument/2006/relationships">
+  <p:cSld>
+    <p:spTree>
+      <p:nvGrpSpPr>
+        <p:cNvPr id="1" name=""/>
+        <p:cNvGrpSpPr/>
+        <p:nvPr/>
+      </p:nvGrpSpPr>
+      <p:grpSpPr/>
+      <p:sp>
+        <p:nvSpPr>
+          <p:cNvPr id="2" name="Title 1"/>
+          <p:cNvSpPr>
+            <a:spLocks noGrp="1"/>
+          </p:cNvSpPr>
+          <p:nvPr>
+            <p:ph type="title"/>
+          </p:nvPr>
+        </p:nvSpPr>
+        <p:spPr/>
+        <p:txBody>
+          <a:bodyPr/>
+          <a:lstStyle/>
+          <a:p>
+            <a:r>
+              <a:t>Conclusão</a:t>
+            </a:r>
+          </a:p>
+        </p:txBody>
+      </p:sp>
+      <p:sp>
+        <p:nvSpPr>
+          <p:cNvPr id="3" name="Content Placeholder 2"/>
+          <p:cNvSpPr>
+            <a:spLocks noGrp="1"/>
+          </p:cNvSpPr>
+          <p:nvPr>
+            <p:ph idx="1"/>
+          </p:nvPr>
+        </p:nvSpPr>
+        <p:spPr/>
+        <p:txBody>
+          <a:bodyPr/>
+          <a:lstStyle/>
+          <a:p/>
+          <a:p>
+            <a:pPr lvl="1">
+              <a:defRPr sz="2000"/>
+            </a:pPr>
+            <a:r>
+              <a:t>A arquitetura distribuída do Spectrum provou que a transição de cargas pesadas para uma execução via filas destrava o treinamento exaustivo sem consumir o maquinário local do analista.</a:t>
+            </a:r>
+          </a:p>
+          <a:p>
+            <a:pPr lvl="1">
+              <a:defRPr sz="2000"/>
+            </a:pPr>
+            <a:r>
+              <a:t>A linguagem estruturada IQL quebra o modelo de observação estática de outras ferramentas, permitindo ao cientista a prospecção e extração guiada de regras específicas imersas nos e-graphs.</a:t>
+            </a:r>
+          </a:p>
+          <a:p>
+            <a:pPr lvl="1">
+              <a:defRPr sz="2000"/>
+            </a:pPr>
+            <a:r>
+              <a:t>Centralizar as visualizações otimizadas acopladas ao redator acadêmico agilizou com eficiência os fluxos metodológicos.</a:t>
+            </a:r>
+          </a:p>
+        </p:txBody>
+      </p:sp>
+    </p:spTree>
+  </p:cSld>
+  <p:clrMapOvr>
+    <a:masterClrMapping/>
+  </p:clrMapOvr>
+</p:sld>
+</file>
+
+<file path=ppt/slides/slide32.xml><?xml version="1.0" encoding="utf-8"?>
+<p:sld xmlns:a="http://schemas.openxmlformats.org/drawingml/2006/main" xmlns:p="http://schemas.openxmlformats.org/presentationml/2006/main" xmlns:r="http://schemas.openxmlformats.org/officeDocument/2006/relationships">
+  <p:cSld>
+    <p:spTree>
+      <p:nvGrpSpPr>
+        <p:cNvPr id="1" name=""/>
+        <p:cNvGrpSpPr/>
+        <p:nvPr/>
+      </p:nvGrpSpPr>
+      <p:grpSpPr/>
+      <p:sp>
+        <p:nvSpPr>
+          <p:cNvPr id="2" name="Title 1"/>
+          <p:cNvSpPr>
+            <a:spLocks noGrp="1"/>
+          </p:cNvSpPr>
+          <p:nvPr>
+            <p:ph type="title"/>
+          </p:nvPr>
+        </p:nvSpPr>
+        <p:spPr/>
+        <p:txBody>
+          <a:bodyPr/>
+          <a:lstStyle/>
+          <a:p>
+            <a:r>
+              <a:t>Trabalhos Futuros</a:t>
+            </a:r>
+          </a:p>
+        </p:txBody>
+      </p:sp>
+      <p:sp>
+        <p:nvSpPr>
+          <p:cNvPr id="3" name="Content Placeholder 2"/>
+          <p:cNvSpPr>
+            <a:spLocks noGrp="1"/>
+          </p:cNvSpPr>
+          <p:nvPr>
+            <p:ph idx="1"/>
+          </p:nvPr>
+        </p:nvSpPr>
+        <p:spPr/>
+        <p:txBody>
+          <a:bodyPr/>
+          <a:lstStyle/>
+          <a:p/>
+          <a:p>
+            <a:pPr lvl="1">
+              <a:defRPr sz="2000"/>
+            </a:pPr>
+            <a:r>
+              <a:t>Resiliência de Rede: Implantar o padrão arquitetural estrito no código do backend para garantir que nenhum processo se perca.</a:t>
+            </a:r>
+          </a:p>
+          <a:p>
+            <a:pPr lvl="1">
+              <a:defRPr sz="2000"/>
+            </a:pPr>
+            <a:r>
+              <a:t>Suporte Estendido: Possibilitar a integração opcional da camada de treinamento para interligar as execuções IQL aos motores otimizados em C++ (ex. PySR).</a:t>
+            </a:r>
+          </a:p>
+          <a:p>
+            <a:pPr lvl="1">
+              <a:defRPr sz="2000"/>
+            </a:pPr>
+            <a:r>
+              <a:t>Tipagens Textuais Avançadas: Expandir o processador de dados para abranger e validar representações em texto, provindas da computação através de embeddings numéricos.</a:t>
+            </a:r>
+          </a:p>
+        </p:txBody>
+      </p:sp>
+    </p:spTree>
+  </p:cSld>
+  <p:clrMapOvr>
+    <a:masterClrMapping/>
+  </p:clrMapOvr>
+</p:sld>
+</file>
+
+<file path=ppt/slides/slide33.xml><?xml version="1.0" encoding="utf-8"?>
 <p:sld xmlns:a="http://schemas.openxmlformats.org/drawingml/2006/main" xmlns:p="http://schemas.openxmlformats.org/presentationml/2006/main" xmlns:r="http://schemas.openxmlformats.org/officeDocument/2006/relationships">
   <p:cSld>
     <p:spTree>

</xml_diff>